<commit_message>
cores in English and docs
</commit_message>
<xml_diff>
--- a/docs/structure.pptx
+++ b/docs/structure.pptx
@@ -260,7 +260,7 @@
           <a:p>
             <a:fld id="{525C2619-F06C-3D42-8D48-5DBF955DAB6E}" type="datetimeFigureOut">
               <a:rPr lang="ru-RU" smtClean="0"/>
-              <a:t>25.05.2026</a:t>
+              <a:t>07.07.2026</a:t>
             </a:fld>
             <a:endParaRPr lang="ru-RU"/>
           </a:p>
@@ -458,7 +458,7 @@
           <a:p>
             <a:fld id="{525C2619-F06C-3D42-8D48-5DBF955DAB6E}" type="datetimeFigureOut">
               <a:rPr lang="ru-RU" smtClean="0"/>
-              <a:t>25.05.2026</a:t>
+              <a:t>07.07.2026</a:t>
             </a:fld>
             <a:endParaRPr lang="ru-RU"/>
           </a:p>
@@ -666,7 +666,7 @@
           <a:p>
             <a:fld id="{525C2619-F06C-3D42-8D48-5DBF955DAB6E}" type="datetimeFigureOut">
               <a:rPr lang="ru-RU" smtClean="0"/>
-              <a:t>25.05.2026</a:t>
+              <a:t>07.07.2026</a:t>
             </a:fld>
             <a:endParaRPr lang="ru-RU"/>
           </a:p>
@@ -864,7 +864,7 @@
           <a:p>
             <a:fld id="{525C2619-F06C-3D42-8D48-5DBF955DAB6E}" type="datetimeFigureOut">
               <a:rPr lang="ru-RU" smtClean="0"/>
-              <a:t>25.05.2026</a:t>
+              <a:t>07.07.2026</a:t>
             </a:fld>
             <a:endParaRPr lang="ru-RU"/>
           </a:p>
@@ -1139,7 +1139,7 @@
           <a:p>
             <a:fld id="{525C2619-F06C-3D42-8D48-5DBF955DAB6E}" type="datetimeFigureOut">
               <a:rPr lang="ru-RU" smtClean="0"/>
-              <a:t>25.05.2026</a:t>
+              <a:t>07.07.2026</a:t>
             </a:fld>
             <a:endParaRPr lang="ru-RU"/>
           </a:p>
@@ -1404,7 +1404,7 @@
           <a:p>
             <a:fld id="{525C2619-F06C-3D42-8D48-5DBF955DAB6E}" type="datetimeFigureOut">
               <a:rPr lang="ru-RU" smtClean="0"/>
-              <a:t>25.05.2026</a:t>
+              <a:t>07.07.2026</a:t>
             </a:fld>
             <a:endParaRPr lang="ru-RU"/>
           </a:p>
@@ -1816,7 +1816,7 @@
           <a:p>
             <a:fld id="{525C2619-F06C-3D42-8D48-5DBF955DAB6E}" type="datetimeFigureOut">
               <a:rPr lang="ru-RU" smtClean="0"/>
-              <a:t>25.05.2026</a:t>
+              <a:t>07.07.2026</a:t>
             </a:fld>
             <a:endParaRPr lang="ru-RU"/>
           </a:p>
@@ -1957,7 +1957,7 @@
           <a:p>
             <a:fld id="{525C2619-F06C-3D42-8D48-5DBF955DAB6E}" type="datetimeFigureOut">
               <a:rPr lang="ru-RU" smtClean="0"/>
-              <a:t>25.05.2026</a:t>
+              <a:t>07.07.2026</a:t>
             </a:fld>
             <a:endParaRPr lang="ru-RU"/>
           </a:p>
@@ -2070,7 +2070,7 @@
           <a:p>
             <a:fld id="{525C2619-F06C-3D42-8D48-5DBF955DAB6E}" type="datetimeFigureOut">
               <a:rPr lang="ru-RU" smtClean="0"/>
-              <a:t>25.05.2026</a:t>
+              <a:t>07.07.2026</a:t>
             </a:fld>
             <a:endParaRPr lang="ru-RU"/>
           </a:p>
@@ -2381,7 +2381,7 @@
           <a:p>
             <a:fld id="{525C2619-F06C-3D42-8D48-5DBF955DAB6E}" type="datetimeFigureOut">
               <a:rPr lang="ru-RU" smtClean="0"/>
-              <a:t>25.05.2026</a:t>
+              <a:t>07.07.2026</a:t>
             </a:fld>
             <a:endParaRPr lang="ru-RU"/>
           </a:p>
@@ -2669,7 +2669,7 @@
           <a:p>
             <a:fld id="{525C2619-F06C-3D42-8D48-5DBF955DAB6E}" type="datetimeFigureOut">
               <a:rPr lang="ru-RU" smtClean="0"/>
-              <a:t>25.05.2026</a:t>
+              <a:t>07.07.2026</a:t>
             </a:fld>
             <a:endParaRPr lang="ru-RU"/>
           </a:p>
@@ -2910,7 +2910,7 @@
           <a:p>
             <a:fld id="{525C2619-F06C-3D42-8D48-5DBF955DAB6E}" type="datetimeFigureOut">
               <a:rPr lang="ru-RU" smtClean="0"/>
-              <a:t>25.05.2026</a:t>
+              <a:t>07.07.2026</a:t>
             </a:fld>
             <a:endParaRPr lang="ru-RU"/>
           </a:p>
@@ -3865,7 +3865,7 @@
           <a:p>
             <a:r>
               <a:rPr lang="en" dirty="0"/>
-              <a:t>Flatten</a:t>
+              <a:t>Flatten, …</a:t>
             </a:r>
             <a:endParaRPr lang="ru-RU" dirty="0"/>
           </a:p>
@@ -4769,13 +4769,14 @@
           </a:p>
           <a:p>
             <a:r>
-              <a:rPr lang="ru-RU" dirty="0">
-                <a:highlight>
-                  <a:srgbClr val="FFFF00"/>
-                </a:highlight>
-              </a:rPr>
-              <a:t>Добавить слой из нескольких ядер!</a:t>
-            </a:r>
+              <a:rPr lang="en" dirty="0" err="1"/>
+              <a:t>SingleCrossbarMatMulLayer</a:t>
+            </a:r>
+            <a:r>
+              <a:rPr lang="en" dirty="0"/>
+              <a:t>, …</a:t>
+            </a:r>
+            <a:endParaRPr lang="ru-RU" dirty="0"/>
           </a:p>
         </p:txBody>
       </p:sp>

</xml_diff>